<commit_message>
Update new tracing to mcp project
</commit_message>
<xml_diff>
--- a/presentation/每日拾光学习簿-项目介绍.pptx
+++ b/presentation/每日拾光学习簿-项目介绍.pptx
@@ -9319,7 +9319,7 @@
               </a:defRPr>
             </a:pPr>
             <a:r>
-              <a:t>●  扫描 5 个 Git 仓库的提交记录</a:t>
+              <a:t>●  扫描 6 个 Git 仓库的提交记录</a:t>
             </a:r>
           </a:p>
           <a:p>
@@ -9893,7 +9893,7 @@
               </a:defRPr>
             </a:pPr>
             <a:r>
-              <a:t>每日自动扫描 ~/projects 下的 5 个 Git 仓库，生成对应工作总结</a:t>
+              <a:t>每日自动扫描 ~/projects 下的 6 个 Git 仓库，生成对应工作总结</a:t>
             </a:r>
           </a:p>
         </p:txBody>
@@ -9906,8 +9906,8 @@
         </p:nvSpPr>
         <p:spPr>
           <a:xfrm>
-            <a:off x="731520" y="2468880"/>
-            <a:ext cx="2011680" cy="3200400"/>
+            <a:off x="731520" y="2240280"/>
+            <a:ext cx="3337560" cy="1234440"/>
           </a:xfrm>
           <a:prstGeom prst="roundRect">
             <a:avLst/>
@@ -9949,8 +9949,8 @@
         </p:nvSpPr>
         <p:spPr>
           <a:xfrm>
-            <a:off x="1417320" y="2743200"/>
-            <a:ext cx="640080" cy="640080"/>
+            <a:off x="1051560" y="2468880"/>
+            <a:ext cx="502920" cy="502920"/>
           </a:xfrm>
           <a:prstGeom prst="ellipse">
             <a:avLst/>
@@ -9992,8 +9992,8 @@
         </p:nvSpPr>
         <p:spPr>
           <a:xfrm>
-            <a:off x="960120" y="3474720"/>
-            <a:ext cx="1554480" cy="274320"/>
+            <a:off x="896112" y="2624328"/>
+            <a:ext cx="320040" cy="219456"/>
           </a:xfrm>
           <a:prstGeom prst="rect">
             <a:avLst/>
@@ -10007,9 +10007,9 @@
           <a:lstStyle/>
           <a:p>
             <a:pPr algn="ctr">
-              <a:defRPr sz="1200" b="0">
-                <a:solidFill>
-                  <a:srgbClr val="999999"/>
+              <a:defRPr sz="1000" b="1">
+                <a:solidFill>
+                  <a:srgbClr val="1A1A2E"/>
                 </a:solidFill>
                 <a:latin typeface="Microsoft YaHei"/>
               </a:defRPr>
@@ -10028,8 +10028,8 @@
         </p:nvSpPr>
         <p:spPr>
           <a:xfrm>
-            <a:off x="822960" y="3749039"/>
-            <a:ext cx="1828800" cy="457200"/>
+            <a:off x="1508760" y="2468880"/>
+            <a:ext cx="2377440" cy="320040"/>
           </a:xfrm>
           <a:prstGeom prst="rect">
             <a:avLst/>
@@ -10042,8 +10042,8 @@
           </a:bodyPr>
           <a:lstStyle/>
           <a:p>
-            <a:pPr algn="ctr">
-              <a:defRPr sz="1800" b="1">
+            <a:pPr algn="l">
+              <a:defRPr sz="1500" b="1">
                 <a:solidFill>
                   <a:srgbClr val="FFFFFF"/>
                 </a:solidFill>
@@ -10064,8 +10064,8 @@
         </p:nvSpPr>
         <p:spPr>
           <a:xfrm>
-            <a:off x="822960" y="4297680"/>
-            <a:ext cx="1828800" cy="548640"/>
+            <a:off x="1508760" y="2898648"/>
+            <a:ext cx="2377440" cy="320040"/>
           </a:xfrm>
           <a:prstGeom prst="rect">
             <a:avLst/>
@@ -10078,8 +10078,8 @@
           </a:bodyPr>
           <a:lstStyle/>
           <a:p>
-            <a:pPr algn="ctr">
-              <a:defRPr sz="1200" b="0">
+            <a:pPr algn="l">
+              <a:defRPr sz="1100" b="0">
                 <a:solidFill>
                   <a:srgbClr val="999999"/>
                 </a:solidFill>
@@ -10100,8 +10100,8 @@
         </p:nvSpPr>
         <p:spPr>
           <a:xfrm>
-            <a:off x="2971800" y="2468880"/>
-            <a:ext cx="2011680" cy="3200400"/>
+            <a:off x="4389120" y="2240280"/>
+            <a:ext cx="3337560" cy="1234440"/>
           </a:xfrm>
           <a:prstGeom prst="roundRect">
             <a:avLst/>
@@ -10143,8 +10143,8 @@
         </p:nvSpPr>
         <p:spPr>
           <a:xfrm>
-            <a:off x="3657600" y="2743200"/>
-            <a:ext cx="640080" cy="640080"/>
+            <a:off x="4709159" y="2468880"/>
+            <a:ext cx="502920" cy="502920"/>
           </a:xfrm>
           <a:prstGeom prst="ellipse">
             <a:avLst/>
@@ -10186,8 +10186,8 @@
         </p:nvSpPr>
         <p:spPr>
           <a:xfrm>
-            <a:off x="3200400" y="3474720"/>
-            <a:ext cx="1554480" cy="274320"/>
+            <a:off x="4553712" y="2624328"/>
+            <a:ext cx="320040" cy="219456"/>
           </a:xfrm>
           <a:prstGeom prst="rect">
             <a:avLst/>
@@ -10201,9 +10201,9 @@
           <a:lstStyle/>
           <a:p>
             <a:pPr algn="ctr">
-              <a:defRPr sz="1200" b="0">
-                <a:solidFill>
-                  <a:srgbClr val="999999"/>
+              <a:defRPr sz="1000" b="1">
+                <a:solidFill>
+                  <a:srgbClr val="1A1A2E"/>
                 </a:solidFill>
                 <a:latin typeface="Microsoft YaHei"/>
               </a:defRPr>
@@ -10222,8 +10222,8 @@
         </p:nvSpPr>
         <p:spPr>
           <a:xfrm>
-            <a:off x="3063240" y="3749039"/>
-            <a:ext cx="1828800" cy="457200"/>
+            <a:off x="5166359" y="2468880"/>
+            <a:ext cx="2377440" cy="320040"/>
           </a:xfrm>
           <a:prstGeom prst="rect">
             <a:avLst/>
@@ -10236,8 +10236,8 @@
           </a:bodyPr>
           <a:lstStyle/>
           <a:p>
-            <a:pPr algn="ctr">
-              <a:defRPr sz="1800" b="1">
+            <a:pPr algn="l">
+              <a:defRPr sz="1500" b="1">
                 <a:solidFill>
                   <a:srgbClr val="FFFFFF"/>
                 </a:solidFill>
@@ -10258,8 +10258,8 @@
         </p:nvSpPr>
         <p:spPr>
           <a:xfrm>
-            <a:off x="3063240" y="4297680"/>
-            <a:ext cx="1828800" cy="548640"/>
+            <a:off x="5166359" y="2898648"/>
+            <a:ext cx="2377440" cy="320040"/>
           </a:xfrm>
           <a:prstGeom prst="rect">
             <a:avLst/>
@@ -10272,8 +10272,8 @@
           </a:bodyPr>
           <a:lstStyle/>
           <a:p>
-            <a:pPr algn="ctr">
-              <a:defRPr sz="1200" b="0">
+            <a:pPr algn="l">
+              <a:defRPr sz="1100" b="0">
                 <a:solidFill>
                   <a:srgbClr val="999999"/>
                 </a:solidFill>
@@ -10294,8 +10294,8 @@
         </p:nvSpPr>
         <p:spPr>
           <a:xfrm>
-            <a:off x="5212080" y="2468880"/>
-            <a:ext cx="2011680" cy="3200400"/>
+            <a:off x="8046720" y="2240280"/>
+            <a:ext cx="3337560" cy="1234440"/>
           </a:xfrm>
           <a:prstGeom prst="roundRect">
             <a:avLst/>
@@ -10337,8 +10337,8 @@
         </p:nvSpPr>
         <p:spPr>
           <a:xfrm>
-            <a:off x="5897880" y="2743200"/>
-            <a:ext cx="640080" cy="640080"/>
+            <a:off x="8366760" y="2468880"/>
+            <a:ext cx="502920" cy="502920"/>
           </a:xfrm>
           <a:prstGeom prst="ellipse">
             <a:avLst/>
@@ -10380,8 +10380,8 @@
         </p:nvSpPr>
         <p:spPr>
           <a:xfrm>
-            <a:off x="5440680" y="3474720"/>
-            <a:ext cx="1554480" cy="274320"/>
+            <a:off x="8211312" y="2624328"/>
+            <a:ext cx="320040" cy="219456"/>
           </a:xfrm>
           <a:prstGeom prst="rect">
             <a:avLst/>
@@ -10395,9 +10395,9 @@
           <a:lstStyle/>
           <a:p>
             <a:pPr algn="ctr">
-              <a:defRPr sz="1200" b="0">
-                <a:solidFill>
-                  <a:srgbClr val="999999"/>
+              <a:defRPr sz="1000" b="1">
+                <a:solidFill>
+                  <a:srgbClr val="1A1A2E"/>
                 </a:solidFill>
                 <a:latin typeface="Microsoft YaHei"/>
               </a:defRPr>
@@ -10416,8 +10416,8 @@
         </p:nvSpPr>
         <p:spPr>
           <a:xfrm>
-            <a:off x="5303520" y="3749039"/>
-            <a:ext cx="1828800" cy="457200"/>
+            <a:off x="8823960" y="2468880"/>
+            <a:ext cx="2377440" cy="320040"/>
           </a:xfrm>
           <a:prstGeom prst="rect">
             <a:avLst/>
@@ -10430,8 +10430,8 @@
           </a:bodyPr>
           <a:lstStyle/>
           <a:p>
-            <a:pPr algn="ctr">
-              <a:defRPr sz="1800" b="1">
+            <a:pPr algn="l">
+              <a:defRPr sz="1500" b="1">
                 <a:solidFill>
                   <a:srgbClr val="FFFFFF"/>
                 </a:solidFill>
@@ -10452,8 +10452,8 @@
         </p:nvSpPr>
         <p:spPr>
           <a:xfrm>
-            <a:off x="5303520" y="4297680"/>
-            <a:ext cx="1828800" cy="548640"/>
+            <a:off x="8823960" y="2898648"/>
+            <a:ext cx="2377440" cy="320040"/>
           </a:xfrm>
           <a:prstGeom prst="rect">
             <a:avLst/>
@@ -10466,8 +10466,8 @@
           </a:bodyPr>
           <a:lstStyle/>
           <a:p>
-            <a:pPr algn="ctr">
-              <a:defRPr sz="1200" b="0">
+            <a:pPr algn="l">
+              <a:defRPr sz="1100" b="0">
                 <a:solidFill>
                   <a:srgbClr val="999999"/>
                 </a:solidFill>
@@ -10488,8 +10488,8 @@
         </p:nvSpPr>
         <p:spPr>
           <a:xfrm>
-            <a:off x="7452360" y="2468880"/>
-            <a:ext cx="2011680" cy="3200400"/>
+            <a:off x="731520" y="3840480"/>
+            <a:ext cx="3337560" cy="1234440"/>
           </a:xfrm>
           <a:prstGeom prst="roundRect">
             <a:avLst/>
@@ -10531,8 +10531,8 @@
         </p:nvSpPr>
         <p:spPr>
           <a:xfrm>
-            <a:off x="8138160" y="2743200"/>
-            <a:ext cx="640080" cy="640080"/>
+            <a:off x="1051560" y="4069080"/>
+            <a:ext cx="502920" cy="502920"/>
           </a:xfrm>
           <a:prstGeom prst="ellipse">
             <a:avLst/>
@@ -10574,8 +10574,8 @@
         </p:nvSpPr>
         <p:spPr>
           <a:xfrm>
-            <a:off x="7680960" y="3474720"/>
-            <a:ext cx="1554480" cy="274320"/>
+            <a:off x="896112" y="4224528"/>
+            <a:ext cx="320040" cy="219456"/>
           </a:xfrm>
           <a:prstGeom prst="rect">
             <a:avLst/>
@@ -10589,9 +10589,9 @@
           <a:lstStyle/>
           <a:p>
             <a:pPr algn="ctr">
-              <a:defRPr sz="1200" b="0">
-                <a:solidFill>
-                  <a:srgbClr val="999999"/>
+              <a:defRPr sz="1000" b="1">
+                <a:solidFill>
+                  <a:srgbClr val="1A1A2E"/>
                 </a:solidFill>
                 <a:latin typeface="Microsoft YaHei"/>
               </a:defRPr>
@@ -10610,8 +10610,8 @@
         </p:nvSpPr>
         <p:spPr>
           <a:xfrm>
-            <a:off x="7543800" y="3749039"/>
-            <a:ext cx="1828800" cy="457200"/>
+            <a:off x="1508760" y="4069080"/>
+            <a:ext cx="2377440" cy="320040"/>
           </a:xfrm>
           <a:prstGeom prst="rect">
             <a:avLst/>
@@ -10624,8 +10624,8 @@
           </a:bodyPr>
           <a:lstStyle/>
           <a:p>
-            <a:pPr algn="ctr">
-              <a:defRPr sz="1800" b="1">
+            <a:pPr algn="l">
+              <a:defRPr sz="1500" b="1">
                 <a:solidFill>
                   <a:srgbClr val="FFFFFF"/>
                 </a:solidFill>
@@ -10646,8 +10646,8 @@
         </p:nvSpPr>
         <p:spPr>
           <a:xfrm>
-            <a:off x="7543800" y="4297680"/>
-            <a:ext cx="1828800" cy="548640"/>
+            <a:off x="1508760" y="4498848"/>
+            <a:ext cx="2377440" cy="320040"/>
           </a:xfrm>
           <a:prstGeom prst="rect">
             <a:avLst/>
@@ -10660,8 +10660,8 @@
           </a:bodyPr>
           <a:lstStyle/>
           <a:p>
-            <a:pPr algn="ctr">
-              <a:defRPr sz="1200" b="0">
+            <a:pPr algn="l">
+              <a:defRPr sz="1100" b="0">
                 <a:solidFill>
                   <a:srgbClr val="999999"/>
                 </a:solidFill>
@@ -10682,8 +10682,8 @@
         </p:nvSpPr>
         <p:spPr>
           <a:xfrm>
-            <a:off x="9692640" y="2468880"/>
-            <a:ext cx="2011680" cy="3200400"/>
+            <a:off x="4389120" y="3840480"/>
+            <a:ext cx="3337560" cy="1234440"/>
           </a:xfrm>
           <a:prstGeom prst="roundRect">
             <a:avLst/>
@@ -10725,8 +10725,8 @@
         </p:nvSpPr>
         <p:spPr>
           <a:xfrm>
-            <a:off x="10378440" y="2743200"/>
-            <a:ext cx="640080" cy="640080"/>
+            <a:off x="4709159" y="4069080"/>
+            <a:ext cx="502920" cy="502920"/>
           </a:xfrm>
           <a:prstGeom prst="ellipse">
             <a:avLst/>
@@ -10768,8 +10768,8 @@
         </p:nvSpPr>
         <p:spPr>
           <a:xfrm>
-            <a:off x="9921240" y="3474720"/>
-            <a:ext cx="1554480" cy="274320"/>
+            <a:off x="4553712" y="4224528"/>
+            <a:ext cx="320040" cy="219456"/>
           </a:xfrm>
           <a:prstGeom prst="rect">
             <a:avLst/>
@@ -10783,9 +10783,9 @@
           <a:lstStyle/>
           <a:p>
             <a:pPr algn="ctr">
-              <a:defRPr sz="1200" b="0">
-                <a:solidFill>
-                  <a:srgbClr val="999999"/>
+              <a:defRPr sz="1000" b="1">
+                <a:solidFill>
+                  <a:srgbClr val="1A1A2E"/>
                 </a:solidFill>
                 <a:latin typeface="Microsoft YaHei"/>
               </a:defRPr>
@@ -10804,8 +10804,8 @@
         </p:nvSpPr>
         <p:spPr>
           <a:xfrm>
-            <a:off x="9784080" y="3749039"/>
-            <a:ext cx="1828800" cy="457200"/>
+            <a:off x="5166359" y="4069080"/>
+            <a:ext cx="2377440" cy="320040"/>
           </a:xfrm>
           <a:prstGeom prst="rect">
             <a:avLst/>
@@ -10818,8 +10818,8 @@
           </a:bodyPr>
           <a:lstStyle/>
           <a:p>
-            <a:pPr algn="ctr">
-              <a:defRPr sz="1800" b="1">
+            <a:pPr algn="l">
+              <a:defRPr sz="1500" b="1">
                 <a:solidFill>
                   <a:srgbClr val="FFFFFF"/>
                 </a:solidFill>
@@ -10840,8 +10840,8 @@
         </p:nvSpPr>
         <p:spPr>
           <a:xfrm>
-            <a:off x="9784080" y="4297680"/>
-            <a:ext cx="1828800" cy="548640"/>
+            <a:off x="5166359" y="4498848"/>
+            <a:ext cx="2377440" cy="320040"/>
           </a:xfrm>
           <a:prstGeom prst="rect">
             <a:avLst/>
@@ -10854,8 +10854,202 @@
           </a:bodyPr>
           <a:lstStyle/>
           <a:p>
+            <a:pPr algn="l">
+              <a:defRPr sz="1100" b="0">
+                <a:solidFill>
+                  <a:srgbClr val="999999"/>
+                </a:solidFill>
+                <a:latin typeface="Microsoft YaHei"/>
+              </a:defRPr>
+            </a:pPr>
+            <a:r>
+              <a:t>论文管理 (Claude Code)</a:t>
+            </a:r>
+          </a:p>
+        </p:txBody>
+      </p:sp>
+      <p:sp>
+        <p:nvSpPr>
+          <p:cNvPr id="30" name="Rounded Rectangle 29"/>
+          <p:cNvSpPr/>
+          <p:nvPr/>
+        </p:nvSpPr>
+        <p:spPr>
+          <a:xfrm>
+            <a:off x="8046720" y="3840480"/>
+            <a:ext cx="3337560" cy="1234440"/>
+          </a:xfrm>
+          <a:prstGeom prst="roundRect">
+            <a:avLst/>
+          </a:prstGeom>
+          <a:solidFill>
+            <a:srgbClr val="25253A"/>
+          </a:solidFill>
+          <a:ln>
+            <a:noFill/>
+          </a:ln>
+        </p:spPr>
+        <p:style>
+          <a:lnRef idx="1">
+            <a:schemeClr val="accent1"/>
+          </a:lnRef>
+          <a:fillRef idx="3">
+            <a:schemeClr val="accent1"/>
+          </a:fillRef>
+          <a:effectRef idx="2">
+            <a:schemeClr val="accent1"/>
+          </a:effectRef>
+          <a:fontRef idx="minor">
+            <a:schemeClr val="lt1"/>
+          </a:fontRef>
+        </p:style>
+        <p:txBody>
+          <a:bodyPr rtlCol="0" anchor="ctr"/>
+          <a:lstStyle/>
+          <a:p>
+            <a:pPr algn="ctr"/>
+          </a:p>
+        </p:txBody>
+      </p:sp>
+      <p:sp>
+        <p:nvSpPr>
+          <p:cNvPr id="31" name="Oval 30"/>
+          <p:cNvSpPr/>
+          <p:nvPr/>
+        </p:nvSpPr>
+        <p:spPr>
+          <a:xfrm>
+            <a:off x="8366760" y="4069080"/>
+            <a:ext cx="502920" cy="502920"/>
+          </a:xfrm>
+          <a:prstGeom prst="ellipse">
+            <a:avLst/>
+          </a:prstGeom>
+          <a:solidFill>
+            <a:srgbClr val="E96B46"/>
+          </a:solidFill>
+          <a:ln>
+            <a:noFill/>
+          </a:ln>
+        </p:spPr>
+        <p:style>
+          <a:lnRef idx="1">
+            <a:schemeClr val="accent1"/>
+          </a:lnRef>
+          <a:fillRef idx="3">
+            <a:schemeClr val="accent1"/>
+          </a:fillRef>
+          <a:effectRef idx="2">
+            <a:schemeClr val="accent1"/>
+          </a:effectRef>
+          <a:fontRef idx="minor">
+            <a:schemeClr val="lt1"/>
+          </a:fontRef>
+        </p:style>
+        <p:txBody>
+          <a:bodyPr rtlCol="0" anchor="ctr"/>
+          <a:lstStyle/>
+          <a:p>
+            <a:pPr algn="ctr"/>
+          </a:p>
+        </p:txBody>
+      </p:sp>
+      <p:sp>
+        <p:nvSpPr>
+          <p:cNvPr id="32" name="TextBox 31"/>
+          <p:cNvSpPr txBox="1"/>
+          <p:nvPr/>
+        </p:nvSpPr>
+        <p:spPr>
+          <a:xfrm>
+            <a:off x="8211312" y="4224528"/>
+            <a:ext cx="320040" cy="219456"/>
+          </a:xfrm>
+          <a:prstGeom prst="rect">
+            <a:avLst/>
+          </a:prstGeom>
+          <a:noFill/>
+        </p:spPr>
+        <p:txBody>
+          <a:bodyPr wrap="square">
+            <a:spAutoFit/>
+          </a:bodyPr>
+          <a:lstStyle/>
+          <a:p>
             <a:pPr algn="ctr">
-              <a:defRPr sz="1200" b="0">
+              <a:defRPr sz="1000" b="1">
+                <a:solidFill>
+                  <a:srgbClr val="1A1A2E"/>
+                </a:solidFill>
+                <a:latin typeface="Microsoft YaHei"/>
+              </a:defRPr>
+            </a:pPr>
+            <a:r>
+              <a:t>6</a:t>
+            </a:r>
+          </a:p>
+        </p:txBody>
+      </p:sp>
+      <p:sp>
+        <p:nvSpPr>
+          <p:cNvPr id="33" name="TextBox 32"/>
+          <p:cNvSpPr txBox="1"/>
+          <p:nvPr/>
+        </p:nvSpPr>
+        <p:spPr>
+          <a:xfrm>
+            <a:off x="8823960" y="4069080"/>
+            <a:ext cx="2377440" cy="320040"/>
+          </a:xfrm>
+          <a:prstGeom prst="rect">
+            <a:avLst/>
+          </a:prstGeom>
+          <a:noFill/>
+        </p:spPr>
+        <p:txBody>
+          <a:bodyPr wrap="square">
+            <a:spAutoFit/>
+          </a:bodyPr>
+          <a:lstStyle/>
+          <a:p>
+            <a:pPr algn="l">
+              <a:defRPr sz="1500" b="1">
+                <a:solidFill>
+                  <a:srgbClr val="FFFFFF"/>
+                </a:solidFill>
+                <a:latin typeface="Microsoft YaHei"/>
+              </a:defRPr>
+            </a:pPr>
+            <a:r>
+              <a:t>mcp</a:t>
+            </a:r>
+          </a:p>
+        </p:txBody>
+      </p:sp>
+      <p:sp>
+        <p:nvSpPr>
+          <p:cNvPr id="34" name="TextBox 33"/>
+          <p:cNvSpPr txBox="1"/>
+          <p:nvPr/>
+        </p:nvSpPr>
+        <p:spPr>
+          <a:xfrm>
+            <a:off x="8823960" y="4498848"/>
+            <a:ext cx="2377440" cy="320040"/>
+          </a:xfrm>
+          <a:prstGeom prst="rect">
+            <a:avLst/>
+          </a:prstGeom>
+          <a:noFill/>
+        </p:spPr>
+        <p:txBody>
+          <a:bodyPr wrap="square">
+            <a:spAutoFit/>
+          </a:bodyPr>
+          <a:lstStyle/>
+          <a:p>
+            <a:pPr algn="l">
+              <a:defRPr sz="1100" b="0">
                 <a:solidFill>
                   <a:srgbClr val="999999"/>
                 </a:solidFill>
@@ -10863,14 +11057,14 @@
               </a:defRPr>
             </a:pPr>
             <a:r>
-              <a:t>论文管理 (Claude Code)</a:t>
-            </a:r>
-          </a:p>
-        </p:txBody>
-      </p:sp>
-      <p:sp>
-        <p:nvSpPr>
-          <p:cNvPr id="30" name="TextBox 29"/>
+              <a:t>MCP 相关实践</a:t>
+            </a:r>
+          </a:p>
+        </p:txBody>
+      </p:sp>
+      <p:sp>
+        <p:nvSpPr>
+          <p:cNvPr id="35" name="TextBox 34"/>
           <p:cNvSpPr txBox="1"/>
           <p:nvPr/>
         </p:nvSpPr>
@@ -12019,7 +12213,7 @@
               </a:defRPr>
             </a:pPr>
             <a:r>
-              <a:t>扫描 5 个仓库的 Git 提交</a:t>
+              <a:t>扫描 6 个仓库的 Git 提交</a:t>
             </a:r>
             <a:br/>
             <a:r>
@@ -12616,7 +12810,7 @@
               </a:defRPr>
             </a:pPr>
             <a:r>
-              <a:t>●  读取前一天 ~/projects 下 5 个仓库的 git log</a:t>
+              <a:t>●  读取前一天 ~/projects 下 6 个仓库的 git log</a:t>
             </a:r>
           </a:p>
           <a:p>
@@ -14072,6 +14266,25 @@
               </a:defRPr>
             </a:pPr>
             <a:r>
+              <a:t>│   ├── work_summary_mcp.md</a:t>
+            </a:r>
+          </a:p>
+          <a:p>
+            <a:pPr algn="l">
+              <a:spcBef>
+                <a:spcPts val="400"/>
+              </a:spcBef>
+              <a:spcAft>
+                <a:spcPts val="0"/>
+              </a:spcAft>
+              <a:defRPr sz="1400" b="0">
+                <a:solidFill>
+                  <a:srgbClr val="FFFFFF"/>
+                </a:solidFill>
+                <a:latin typeface="Microsoft YaHei"/>
+              </a:defRPr>
+            </a:pPr>
+            <a:r>
               <a:t>│   ├── concept_relevance.md</a:t>
             </a:r>
           </a:p>
@@ -14428,7 +14641,7 @@
               </a:defRPr>
             </a:pPr>
             <a:r>
-              <a:t>    5 个仓库的提交记录</a:t>
+              <a:t>    6 个仓库的提交记录</a:t>
             </a:r>
           </a:p>
           <a:p>

</xml_diff>